<commit_message>
Final changes in the ppt
</commit_message>
<xml_diff>
--- a/MNP/Sem-6-ppt.pptx
+++ b/MNP/Sem-6-ppt.pptx
@@ -5,7 +5,7 @@
     <p:sldMasterId id="2147483658" r:id="rId1"/>
   </p:sldMasterIdLst>
   <p:notesMasterIdLst>
-    <p:notesMasterId r:id="rId23"/>
+    <p:notesMasterId r:id="rId24"/>
   </p:notesMasterIdLst>
   <p:sldIdLst>
     <p:sldId id="256" r:id="rId2"/>
@@ -27,22 +27,23 @@
     <p:sldId id="268" r:id="rId18"/>
     <p:sldId id="269" r:id="rId19"/>
     <p:sldId id="270" r:id="rId20"/>
-    <p:sldId id="271" r:id="rId21"/>
-    <p:sldId id="272" r:id="rId22"/>
+    <p:sldId id="277" r:id="rId21"/>
+    <p:sldId id="271" r:id="rId22"/>
+    <p:sldId id="272" r:id="rId23"/>
   </p:sldIdLst>
   <p:sldSz cx="12192000" cy="6858000"/>
   <p:notesSz cx="6858000" cy="9144000"/>
   <p:embeddedFontLst>
     <p:embeddedFont>
       <p:font typeface="Montserrat" pitchFamily="2" charset="77"/>
-      <p:regular r:id="rId24"/>
-      <p:bold r:id="rId25"/>
-      <p:italic r:id="rId26"/>
-      <p:boldItalic r:id="rId27"/>
+      <p:regular r:id="rId25"/>
+      <p:bold r:id="rId26"/>
+      <p:italic r:id="rId27"/>
+      <p:boldItalic r:id="rId28"/>
     </p:embeddedFont>
     <p:embeddedFont>
       <p:font typeface="Pacifico" pitchFamily="2" charset="77"/>
-      <p:regular r:id="rId28"/>
+      <p:regular r:id="rId29"/>
     </p:embeddedFont>
   </p:embeddedFontLst>
   <p:defaultTextStyle>
@@ -2189,6 +2190,133 @@
   <p:cSld>
     <p:spTree>
       <p:nvGrpSpPr>
+        <p:cNvPr id="1" name="Shape 192">
+          <a:extLst>
+            <a:ext uri="{FF2B5EF4-FFF2-40B4-BE49-F238E27FC236}">
+              <a16:creationId xmlns:a16="http://schemas.microsoft.com/office/drawing/2014/main" id="{70BE8CDF-0595-A62D-6B83-B13FA97D16E0}"/>
+            </a:ext>
+          </a:extLst>
+        </p:cNvPr>
+        <p:cNvGrpSpPr/>
+        <p:nvPr/>
+      </p:nvGrpSpPr>
+      <p:grpSpPr>
+        <a:xfrm>
+          <a:off x="0" y="0"/>
+          <a:ext cx="0" cy="0"/>
+          <a:chOff x="0" y="0"/>
+          <a:chExt cx="0" cy="0"/>
+        </a:xfrm>
+      </p:grpSpPr>
+      <p:sp>
+        <p:nvSpPr>
+          <p:cNvPr id="193" name="Google Shape;193;gf8dcb44881_0_60:notes">
+            <a:extLst>
+              <a:ext uri="{FF2B5EF4-FFF2-40B4-BE49-F238E27FC236}">
+                <a16:creationId xmlns:a16="http://schemas.microsoft.com/office/drawing/2014/main" id="{ECD60EE6-86A6-04AA-62E5-05BBD0B591A6}"/>
+              </a:ext>
+            </a:extLst>
+          </p:cNvPr>
+          <p:cNvSpPr>
+            <a:spLocks noGrp="1" noRot="1" noChangeAspect="1"/>
+          </p:cNvSpPr>
+          <p:nvPr>
+            <p:ph type="sldImg" idx="2"/>
+          </p:nvPr>
+        </p:nvSpPr>
+        <p:spPr>
+          <a:xfrm>
+            <a:off x="381000" y="685800"/>
+            <a:ext cx="6096000" cy="3429000"/>
+          </a:xfrm>
+          <a:custGeom>
+            <a:avLst/>
+            <a:gdLst/>
+            <a:ahLst/>
+            <a:cxnLst/>
+            <a:rect l="l" t="t" r="r" b="b"/>
+            <a:pathLst>
+              <a:path w="120000" h="120000" extrusionOk="0">
+                <a:moveTo>
+                  <a:pt x="0" y="0"/>
+                </a:moveTo>
+                <a:lnTo>
+                  <a:pt x="120000" y="0"/>
+                </a:lnTo>
+                <a:lnTo>
+                  <a:pt x="120000" y="120000"/>
+                </a:lnTo>
+                <a:lnTo>
+                  <a:pt x="0" y="120000"/>
+                </a:lnTo>
+                <a:close/>
+              </a:path>
+            </a:pathLst>
+          </a:custGeom>
+        </p:spPr>
+      </p:sp>
+      <p:sp>
+        <p:nvSpPr>
+          <p:cNvPr id="194" name="Google Shape;194;gf8dcb44881_0_60:notes">
+            <a:extLst>
+              <a:ext uri="{FF2B5EF4-FFF2-40B4-BE49-F238E27FC236}">
+                <a16:creationId xmlns:a16="http://schemas.microsoft.com/office/drawing/2014/main" id="{94589ED7-C8AD-9E90-BA65-2EA2958138B3}"/>
+              </a:ext>
+            </a:extLst>
+          </p:cNvPr>
+          <p:cNvSpPr txBox="1">
+            <a:spLocks noGrp="1"/>
+          </p:cNvSpPr>
+          <p:nvPr>
+            <p:ph type="body" idx="1"/>
+          </p:nvPr>
+        </p:nvSpPr>
+        <p:spPr>
+          <a:xfrm>
+            <a:off x="685800" y="4343400"/>
+            <a:ext cx="5486400" cy="4114800"/>
+          </a:xfrm>
+          <a:prstGeom prst="rect">
+            <a:avLst/>
+          </a:prstGeom>
+        </p:spPr>
+        <p:txBody>
+          <a:bodyPr spcFirstLastPara="1" wrap="square" lIns="91425" tIns="91425" rIns="91425" bIns="91425" anchor="t" anchorCtr="0">
+            <a:noAutofit/>
+          </a:bodyPr>
+          <a:lstStyle/>
+          <a:p>
+            <a:pPr marL="0" lvl="0" indent="0" algn="l" rtl="0">
+              <a:spcBef>
+                <a:spcPts val="0"/>
+              </a:spcBef>
+              <a:spcAft>
+                <a:spcPts val="0"/>
+              </a:spcAft>
+              <a:buNone/>
+            </a:pPr>
+            <a:endParaRPr/>
+          </a:p>
+        </p:txBody>
+      </p:sp>
+    </p:spTree>
+    <p:extLst>
+      <p:ext uri="{BB962C8B-B14F-4D97-AF65-F5344CB8AC3E}">
+        <p14:creationId xmlns:p14="http://schemas.microsoft.com/office/powerpoint/2010/main" val="3557167096"/>
+      </p:ext>
+    </p:extLst>
+  </p:cSld>
+  <p:clrMapOvr>
+    <a:masterClrMapping/>
+  </p:clrMapOvr>
+</p:notes>
+</file>
+
+<file path=ppt/notesSlides/notesSlide21.xml><?xml version="1.0" encoding="utf-8"?>
+<p:notes xmlns:a="http://schemas.openxmlformats.org/drawingml/2006/main" xmlns:r="http://schemas.openxmlformats.org/officeDocument/2006/relationships" xmlns:p="http://schemas.openxmlformats.org/presentationml/2006/main" showMasterSp="0" showMasterPhAnim="0">
+  <p:cSld>
+    <p:spTree>
+      <p:nvGrpSpPr>
         <p:cNvPr id="1" name="Shape 200"/>
         <p:cNvGrpSpPr/>
         <p:nvPr/>
@@ -2288,7 +2416,7 @@
 </p:notes>
 </file>
 
-<file path=ppt/notesSlides/notesSlide21.xml><?xml version="1.0" encoding="utf-8"?>
+<file path=ppt/notesSlides/notesSlide22.xml><?xml version="1.0" encoding="utf-8"?>
 <p:notes xmlns:a="http://schemas.openxmlformats.org/drawingml/2006/main" xmlns:r="http://schemas.openxmlformats.org/officeDocument/2006/relationships" xmlns:p="http://schemas.openxmlformats.org/presentationml/2006/main" showMasterSp="0" showMasterPhAnim="0">
   <p:cSld>
     <p:spTree>
@@ -21022,7 +21150,7 @@
         </p:nvSpPr>
         <p:spPr>
           <a:xfrm>
-            <a:off x="838200" y="365125"/>
+            <a:off x="838200" y="6204"/>
             <a:ext cx="10515600" cy="1145400"/>
           </a:xfrm>
           <a:prstGeom prst="rect">
@@ -21051,7 +21179,7 @@
                 <a:cs typeface="Times New Roman" panose="02020603050405020304" pitchFamily="18" charset="0"/>
                 <a:sym typeface="Nunito"/>
               </a:rPr>
-              <a:t>Conclusion</a:t>
+              <a:t>Results</a:t>
             </a:r>
             <a:endParaRPr sz="3600" b="1" dirty="0">
               <a:latin typeface="Times New Roman" panose="02020603050405020304" pitchFamily="18" charset="0"/>
@@ -21227,6 +21355,36 @@
           </a:p>
         </p:txBody>
       </p:sp>
+      <p:pic>
+        <p:nvPicPr>
+          <p:cNvPr id="4" name="Picture 3" descr="A screenshot of a computer&#10;&#10;Description automatically generated">
+            <a:extLst>
+              <a:ext uri="{FF2B5EF4-FFF2-40B4-BE49-F238E27FC236}">
+                <a16:creationId xmlns:a16="http://schemas.microsoft.com/office/drawing/2014/main" id="{AEFC0926-102A-F8CA-2282-2D2DE14BE226}"/>
+              </a:ext>
+            </a:extLst>
+          </p:cNvPr>
+          <p:cNvPicPr>
+            <a:picLocks noChangeAspect="1"/>
+          </p:cNvPicPr>
+          <p:nvPr/>
+        </p:nvPicPr>
+        <p:blipFill>
+          <a:blip r:embed="rId4"/>
+          <a:stretch>
+            <a:fillRect/>
+          </a:stretch>
+        </p:blipFill>
+        <p:spPr>
+          <a:xfrm>
+            <a:off x="1463842" y="1092425"/>
+            <a:ext cx="10096099" cy="4857750"/>
+          </a:xfrm>
+          <a:prstGeom prst="rect">
+            <a:avLst/>
+          </a:prstGeom>
+        </p:spPr>
+      </p:pic>
     </p:spTree>
   </p:cSld>
   <p:clrMapOvr>
@@ -24852,6 +25010,341 @@
   <p:cSld>
     <p:spTree>
       <p:nvGrpSpPr>
+        <p:cNvPr id="1" name="Shape 195">
+          <a:extLst>
+            <a:ext uri="{FF2B5EF4-FFF2-40B4-BE49-F238E27FC236}">
+              <a16:creationId xmlns:a16="http://schemas.microsoft.com/office/drawing/2014/main" id="{2F0613AD-8E53-26A8-6B98-0F4200E8F4F8}"/>
+            </a:ext>
+          </a:extLst>
+        </p:cNvPr>
+        <p:cNvGrpSpPr/>
+        <p:nvPr/>
+      </p:nvGrpSpPr>
+      <p:grpSpPr>
+        <a:xfrm>
+          <a:off x="0" y="0"/>
+          <a:ext cx="0" cy="0"/>
+          <a:chOff x="0" y="0"/>
+          <a:chExt cx="0" cy="0"/>
+        </a:xfrm>
+      </p:grpSpPr>
+      <p:sp>
+        <p:nvSpPr>
+          <p:cNvPr id="196" name="Google Shape;196;p26">
+            <a:extLst>
+              <a:ext uri="{FF2B5EF4-FFF2-40B4-BE49-F238E27FC236}">
+                <a16:creationId xmlns:a16="http://schemas.microsoft.com/office/drawing/2014/main" id="{BDDCF4EC-A72F-2E9E-047D-3BD075D88A32}"/>
+              </a:ext>
+            </a:extLst>
+          </p:cNvPr>
+          <p:cNvSpPr txBox="1">
+            <a:spLocks noGrp="1"/>
+          </p:cNvSpPr>
+          <p:nvPr>
+            <p:ph type="title"/>
+          </p:nvPr>
+        </p:nvSpPr>
+        <p:spPr>
+          <a:xfrm>
+            <a:off x="838200" y="365125"/>
+            <a:ext cx="10515600" cy="1145400"/>
+          </a:xfrm>
+          <a:prstGeom prst="rect">
+            <a:avLst/>
+          </a:prstGeom>
+        </p:spPr>
+        <p:txBody>
+          <a:bodyPr spcFirstLastPara="1" wrap="square" lIns="91425" tIns="45700" rIns="91425" bIns="45700" anchor="ctr" anchorCtr="0">
+            <a:normAutofit/>
+          </a:bodyPr>
+          <a:lstStyle/>
+          <a:p>
+            <a:pPr marL="0" lvl="0" indent="0" algn="ctr" rtl="0">
+              <a:spcBef>
+                <a:spcPts val="0"/>
+              </a:spcBef>
+              <a:spcAft>
+                <a:spcPts val="0"/>
+              </a:spcAft>
+              <a:buNone/>
+            </a:pPr>
+            <a:r>
+              <a:rPr lang="en-US" sz="3600" b="1" dirty="0">
+                <a:latin typeface="Times New Roman" panose="02020603050405020304" pitchFamily="18" charset="0"/>
+                <a:ea typeface="Nunito"/>
+                <a:cs typeface="Times New Roman" panose="02020603050405020304" pitchFamily="18" charset="0"/>
+                <a:sym typeface="Nunito"/>
+              </a:rPr>
+              <a:t>Conclusion</a:t>
+            </a:r>
+            <a:endParaRPr sz="3600" b="1" dirty="0">
+              <a:latin typeface="Times New Roman" panose="02020603050405020304" pitchFamily="18" charset="0"/>
+              <a:ea typeface="Nunito"/>
+              <a:cs typeface="Times New Roman" panose="02020603050405020304" pitchFamily="18" charset="0"/>
+              <a:sym typeface="Nunito"/>
+            </a:endParaRPr>
+          </a:p>
+        </p:txBody>
+      </p:sp>
+      <p:sp>
+        <p:nvSpPr>
+          <p:cNvPr id="197" name="Google Shape;197;p26">
+            <a:extLst>
+              <a:ext uri="{FF2B5EF4-FFF2-40B4-BE49-F238E27FC236}">
+                <a16:creationId xmlns:a16="http://schemas.microsoft.com/office/drawing/2014/main" id="{D616CD93-C46A-87E1-F998-92484BA99022}"/>
+              </a:ext>
+            </a:extLst>
+          </p:cNvPr>
+          <p:cNvSpPr txBox="1">
+            <a:spLocks noGrp="1"/>
+          </p:cNvSpPr>
+          <p:nvPr>
+            <p:ph type="body" idx="1"/>
+          </p:nvPr>
+        </p:nvSpPr>
+        <p:spPr>
+          <a:xfrm>
+            <a:off x="838200" y="1445288"/>
+            <a:ext cx="10858500" cy="4558200"/>
+          </a:xfrm>
+          <a:prstGeom prst="rect">
+            <a:avLst/>
+          </a:prstGeom>
+        </p:spPr>
+        <p:txBody>
+          <a:bodyPr spcFirstLastPara="1" wrap="square" lIns="91425" tIns="45700" rIns="91425" bIns="45700" anchor="t" anchorCtr="0">
+            <a:noAutofit/>
+          </a:bodyPr>
+          <a:lstStyle/>
+          <a:p>
+            <a:pPr marL="0" lvl="0" indent="0" algn="l" rtl="0">
+              <a:lnSpc>
+                <a:spcPct val="200000"/>
+              </a:lnSpc>
+              <a:spcBef>
+                <a:spcPts val="600"/>
+              </a:spcBef>
+              <a:spcAft>
+                <a:spcPts val="0"/>
+              </a:spcAft>
+              <a:buNone/>
+            </a:pPr>
+            <a:endParaRPr sz="1600" dirty="0">
+              <a:latin typeface="Montserrat"/>
+              <a:ea typeface="Montserrat"/>
+              <a:cs typeface="Montserrat"/>
+              <a:sym typeface="Montserrat"/>
+            </a:endParaRPr>
+          </a:p>
+          <a:p>
+            <a:pPr marL="457200" lvl="0" indent="-330200" algn="l" rtl="0">
+              <a:lnSpc>
+                <a:spcPct val="200000"/>
+              </a:lnSpc>
+              <a:spcBef>
+                <a:spcPts val="600"/>
+              </a:spcBef>
+              <a:spcAft>
+                <a:spcPts val="0"/>
+              </a:spcAft>
+              <a:buSzPts val="1600"/>
+              <a:buFont typeface="Montserrat"/>
+              <a:buChar char="•"/>
+            </a:pPr>
+            <a:endParaRPr sz="1600" dirty="0">
+              <a:latin typeface="Montserrat"/>
+              <a:ea typeface="Montserrat"/>
+              <a:cs typeface="Montserrat"/>
+              <a:sym typeface="Montserrat"/>
+            </a:endParaRPr>
+          </a:p>
+          <a:p>
+            <a:pPr marL="457200" lvl="0" indent="0" algn="l" rtl="0">
+              <a:lnSpc>
+                <a:spcPct val="200000"/>
+              </a:lnSpc>
+              <a:spcBef>
+                <a:spcPts val="1000"/>
+              </a:spcBef>
+              <a:spcAft>
+                <a:spcPts val="0"/>
+              </a:spcAft>
+              <a:buNone/>
+            </a:pPr>
+            <a:endParaRPr sz="1600" dirty="0">
+              <a:highlight>
+                <a:srgbClr val="FFFF00"/>
+              </a:highlight>
+              <a:latin typeface="Montserrat"/>
+              <a:ea typeface="Montserrat"/>
+              <a:cs typeface="Montserrat"/>
+              <a:sym typeface="Montserrat"/>
+            </a:endParaRPr>
+          </a:p>
+        </p:txBody>
+      </p:sp>
+      <p:pic>
+        <p:nvPicPr>
+          <p:cNvPr id="198" name="Google Shape;198;p26" descr="https://lh5.googleusercontent.com/j7Ls_vbKtRxdnDBfbOpGURj9YiFopNGdIM6Kni8LFjJLkuL-dM0u-OU7bkvXbXWzmEWvRtQd51iRQ1Yk-NqjoD2KnvMnPYR6_q5f0vpAIrOpnxWE3ssO6KqdsyWHpN5H2z-y_y_cfDKt7876sA">
+            <a:extLst>
+              <a:ext uri="{FF2B5EF4-FFF2-40B4-BE49-F238E27FC236}">
+                <a16:creationId xmlns:a16="http://schemas.microsoft.com/office/drawing/2014/main" id="{6F19DB4A-7C77-EFD9-C704-113DEE605CE5}"/>
+              </a:ext>
+            </a:extLst>
+          </p:cNvPr>
+          <p:cNvPicPr preferRelativeResize="0"/>
+          <p:nvPr/>
+        </p:nvPicPr>
+        <p:blipFill rotWithShape="1">
+          <a:blip r:embed="rId3">
+            <a:alphaModFix/>
+          </a:blip>
+          <a:srcRect/>
+          <a:stretch/>
+        </p:blipFill>
+        <p:spPr>
+          <a:xfrm>
+            <a:off x="155520" y="81745"/>
+            <a:ext cx="1709654" cy="1010680"/>
+          </a:xfrm>
+          <a:prstGeom prst="rect">
+            <a:avLst/>
+          </a:prstGeom>
+          <a:noFill/>
+          <a:ln>
+            <a:noFill/>
+          </a:ln>
+        </p:spPr>
+      </p:pic>
+      <p:sp>
+        <p:nvSpPr>
+          <p:cNvPr id="199" name="Google Shape;199;p26">
+            <a:extLst>
+              <a:ext uri="{FF2B5EF4-FFF2-40B4-BE49-F238E27FC236}">
+                <a16:creationId xmlns:a16="http://schemas.microsoft.com/office/drawing/2014/main" id="{F95BCD23-C176-5FB6-A42B-5EEC321F84BF}"/>
+              </a:ext>
+            </a:extLst>
+          </p:cNvPr>
+          <p:cNvSpPr txBox="1">
+            <a:spLocks noGrp="1"/>
+          </p:cNvSpPr>
+          <p:nvPr>
+            <p:ph type="sldNum" idx="12"/>
+          </p:nvPr>
+        </p:nvSpPr>
+        <p:spPr>
+          <a:xfrm>
+            <a:off x="8610600" y="6356350"/>
+            <a:ext cx="2743200" cy="365100"/>
+          </a:xfrm>
+          <a:prstGeom prst="rect">
+            <a:avLst/>
+          </a:prstGeom>
+        </p:spPr>
+        <p:txBody>
+          <a:bodyPr spcFirstLastPara="1" wrap="square" lIns="91425" tIns="45700" rIns="91425" bIns="45700" anchor="ctr" anchorCtr="0">
+            <a:noAutofit/>
+          </a:bodyPr>
+          <a:lstStyle/>
+          <a:p>
+            <a:pPr marL="0" lvl="0" indent="0" algn="r" rtl="0">
+              <a:spcBef>
+                <a:spcPts val="0"/>
+              </a:spcBef>
+              <a:spcAft>
+                <a:spcPts val="0"/>
+              </a:spcAft>
+              <a:buClr>
+                <a:srgbClr val="000000"/>
+              </a:buClr>
+              <a:buSzPts val="1200"/>
+              <a:buFont typeface="Arial"/>
+              <a:buNone/>
+            </a:pPr>
+            <a:fld id="{00000000-1234-1234-1234-123412341234}" type="slidenum">
+              <a:rPr lang="en-US"/>
+              <a:t>20</a:t>
+            </a:fld>
+            <a:endParaRPr/>
+          </a:p>
+        </p:txBody>
+      </p:sp>
+      <p:sp>
+        <p:nvSpPr>
+          <p:cNvPr id="2" name="TextBox 1">
+            <a:extLst>
+              <a:ext uri="{FF2B5EF4-FFF2-40B4-BE49-F238E27FC236}">
+                <a16:creationId xmlns:a16="http://schemas.microsoft.com/office/drawing/2014/main" id="{C1694170-8CD0-C67F-4C70-5ACB7CBE2D43}"/>
+              </a:ext>
+            </a:extLst>
+          </p:cNvPr>
+          <p:cNvSpPr txBox="1"/>
+          <p:nvPr/>
+        </p:nvSpPr>
+        <p:spPr>
+          <a:xfrm>
+            <a:off x="495300" y="1967750"/>
+            <a:ext cx="10858500" cy="1815882"/>
+          </a:xfrm>
+          <a:prstGeom prst="rect">
+            <a:avLst/>
+          </a:prstGeom>
+          <a:noFill/>
+        </p:spPr>
+        <p:txBody>
+          <a:bodyPr wrap="square" rtlCol="0">
+            <a:spAutoFit/>
+          </a:bodyPr>
+          <a:lstStyle/>
+          <a:p>
+            <a:r>
+              <a:rPr lang="en-US" sz="1600" dirty="0">
+                <a:latin typeface="Times New Roman" panose="02020603050405020304" pitchFamily="18" charset="0"/>
+                <a:cs typeface="Times New Roman" panose="02020603050405020304" pitchFamily="18" charset="0"/>
+              </a:rPr>
+              <a:t>In conclusion, this project successfully implemented a YOLOv5-based deep learning model for football player detection, utilizing a custom dataset tailored to real-match scenarios. The model demonstrated strong accuracy through high </a:t>
+            </a:r>
+            <a:r>
+              <a:rPr lang="en-US" sz="1600" dirty="0" err="1">
+                <a:latin typeface="Times New Roman" panose="02020603050405020304" pitchFamily="18" charset="0"/>
+                <a:cs typeface="Times New Roman" panose="02020603050405020304" pitchFamily="18" charset="0"/>
+              </a:rPr>
+              <a:t>mAP</a:t>
+            </a:r>
+            <a:r>
+              <a:rPr lang="en-US" sz="1600" dirty="0">
+                <a:latin typeface="Times New Roman" panose="02020603050405020304" pitchFamily="18" charset="0"/>
+                <a:cs typeface="Times New Roman" panose="02020603050405020304" pitchFamily="18" charset="0"/>
+              </a:rPr>
+              <a:t> scores, indicating its effectiveness in recognizing and classifying different types of players on the field. This achievement not only validates the use of AI in sports analytics but also opens the door to automating match analysis, tracking player movement, and generating performance-based insights. By bridging computer vision with football analytics, this project lays the foundation for future advancements in real-time strategic decision-making and enhanced viewer engagement.</a:t>
+            </a:r>
+          </a:p>
+          <a:p>
+            <a:endParaRPr lang="en-US" sz="1600" dirty="0">
+              <a:latin typeface="Times New Roman" panose="02020603050405020304" pitchFamily="18" charset="0"/>
+              <a:cs typeface="Times New Roman" panose="02020603050405020304" pitchFamily="18" charset="0"/>
+            </a:endParaRPr>
+          </a:p>
+        </p:txBody>
+      </p:sp>
+    </p:spTree>
+    <p:extLst>
+      <p:ext uri="{BB962C8B-B14F-4D97-AF65-F5344CB8AC3E}">
+        <p14:creationId xmlns:p14="http://schemas.microsoft.com/office/powerpoint/2010/main" val="1895429043"/>
+      </p:ext>
+    </p:extLst>
+  </p:cSld>
+  <p:clrMapOvr>
+    <a:masterClrMapping/>
+  </p:clrMapOvr>
+</p:sld>
+</file>
+
+<file path=ppt/slides/slide21.xml><?xml version="1.0" encoding="utf-8"?>
+<p:sld xmlns:a="http://schemas.openxmlformats.org/drawingml/2006/main" xmlns:r="http://schemas.openxmlformats.org/officeDocument/2006/relationships" xmlns:p="http://schemas.openxmlformats.org/presentationml/2006/main">
+  <p:cSld>
+    <p:spTree>
+      <p:nvGrpSpPr>
         <p:cNvPr id="1" name="Shape 203"/>
         <p:cNvGrpSpPr/>
         <p:nvPr/>
@@ -25132,7 +25625,7 @@
             </a:pPr>
             <a:fld id="{00000000-1234-1234-1234-123412341234}" type="slidenum">
               <a:rPr lang="en-US"/>
-              <a:t>20</a:t>
+              <a:t>21</a:t>
             </a:fld>
             <a:endParaRPr/>
           </a:p>
@@ -25146,7 +25639,7 @@
 </p:sld>
 </file>
 
-<file path=ppt/slides/slide21.xml><?xml version="1.0" encoding="utf-8"?>
+<file path=ppt/slides/slide22.xml><?xml version="1.0" encoding="utf-8"?>
 <p:sld xmlns:a="http://schemas.openxmlformats.org/drawingml/2006/main" xmlns:r="http://schemas.openxmlformats.org/officeDocument/2006/relationships" xmlns:p="http://schemas.openxmlformats.org/presentationml/2006/main">
   <p:cSld>
     <p:spTree>
@@ -25283,7 +25776,7 @@
             </a:pPr>
             <a:fld id="{00000000-1234-1234-1234-123412341234}" type="slidenum">
               <a:rPr lang="en-US"/>
-              <a:t>21</a:t>
+              <a:t>22</a:t>
             </a:fld>
             <a:endParaRPr/>
           </a:p>

</xml_diff>